<commit_message>
System Design vi: sd-14-032 deck corrected for the SHA-256 / GCM explanation
Co-Authored-By: Claude Sonnet 5.5 <noreply@anthropic.com>
Claude-Session: https://claude.ai/code/session_01WnjciXNJBLEd8jy3HrG49S
</commit_message>
<xml_diff>
--- a/system-design-101/vi/lessons/sd-14-032/slides/sd-14-032.pptx
+++ b/system-design-101/vi/lessons/sd-14-032/slides/sd-14-032.pptx
@@ -5006,10 +5006,10 @@
                 <a:ea typeface="Be Vietnam Pro" pitchFamily="34" charset="-122"/>
                 <a:cs typeface="Be Vietnam Pro" pitchFamily="34" charset="-120"/>
               </a:rPr>
-              <a:t> dùng AES</a:t>
-            </a:r>
-            <a:r>
-              <a:rPr lang="en-US" sz="1800" dirty="0" spc="12" kern="0">
+              <a:t> dùng AES mã</a:t>
+            </a:r>
+            <a:r>
+              <a:rPr lang="en-US" sz="1800" dirty="0" spc="-1" kern="0">
                 <a:solidFill>
                   <a:srgbClr val="D8D3C4"/>
                 </a:solidFill>
@@ -5017,7 +5017,29 @@
                 <a:ea typeface="Be Vietnam Pro" pitchFamily="34" charset="-122"/>
                 <a:cs typeface="Be Vietnam Pro" pitchFamily="34" charset="-120"/>
               </a:rPr>
-              <a:t> để</a:t>
+              <a:t> hóa</a:t>
+            </a:r>
+            <a:r>
+              <a:rPr lang="en-US" sz="1800" dirty="0" spc="-2" kern="0">
+                <a:solidFill>
+                  <a:srgbClr val="D8D3C4"/>
+                </a:solidFill>
+                <a:latin typeface="Be Vietnam Pro" pitchFamily="34" charset="0"/>
+                <a:ea typeface="Be Vietnam Pro" pitchFamily="34" charset="-122"/>
+                <a:cs typeface="Be Vietnam Pro" pitchFamily="34" charset="-120"/>
+              </a:rPr>
+              <a:t> thông</a:t>
+            </a:r>
+            <a:r>
+              <a:rPr lang="en-US" sz="1800" dirty="0" spc="14" kern="0">
+                <a:solidFill>
+                  <a:srgbClr val="D8D3C4"/>
+                </a:solidFill>
+                <a:latin typeface="Be Vietnam Pro" pitchFamily="34" charset="0"/>
+                <a:ea typeface="Be Vietnam Pro" pitchFamily="34" charset="-122"/>
+                <a:cs typeface="Be Vietnam Pro" pitchFamily="34" charset="-120"/>
+              </a:rPr>
+              <a:t> điệp</a:t>
             </a:r>
             <a:r>
               <a:rPr lang="en-US" sz="1800" dirty="0" spc="-1" kern="0">
@@ -5028,10 +5050,10 @@
                 <a:ea typeface="Be Vietnam Pro" pitchFamily="34" charset="-122"/>
                 <a:cs typeface="Be Vietnam Pro" pitchFamily="34" charset="-120"/>
               </a:rPr>
-              <a:t> mã hóa</a:t>
-            </a:r>
-            <a:r>
-              <a:rPr lang="en-US" sz="1800" dirty="0" spc="-3" kern="0">
+              <a:t> dài,</a:t>
+            </a:r>
+            <a:r>
+              <a:rPr lang="en-US" sz="1800" dirty="0" spc="9" kern="0">
                 <a:solidFill>
                   <a:srgbClr val="D8D3C4"/>
                 </a:solidFill>
@@ -5039,10 +5061,10 @@
                 <a:ea typeface="Be Vietnam Pro" pitchFamily="34" charset="-122"/>
                 <a:cs typeface="Be Vietnam Pro" pitchFamily="34" charset="-120"/>
               </a:rPr>
-              <a:t> thông</a:t>
-            </a:r>
-            <a:r>
-              <a:rPr lang="en-US" sz="1800" dirty="0" spc="15" kern="0">
+              <a:t> vừa</a:t>
+            </a:r>
+            <a:r>
+              <a:rPr lang="en-US" sz="1800" dirty="0" spc="-11" kern="0">
                 <a:solidFill>
                   <a:srgbClr val="D8D3C4"/>
                 </a:solidFill>
@@ -5050,10 +5072,10 @@
                 <a:ea typeface="Be Vietnam Pro" pitchFamily="34" charset="-122"/>
                 <a:cs typeface="Be Vietnam Pro" pitchFamily="34" charset="-120"/>
               </a:rPr>
-              <a:t> điệp</a:t>
-            </a:r>
-            <a:r>
-              <a:rPr lang="en-US" sz="1800" dirty="0" spc="0" kern="0">
+              <a:t> gắn</a:t>
+            </a:r>
+            <a:r>
+              <a:rPr lang="en-US" sz="1800" dirty="0" spc="-2" kern="0">
                 <a:solidFill>
                   <a:srgbClr val="D8D3C4"/>
                 </a:solidFill>
@@ -5061,10 +5083,10 @@
                 <a:ea typeface="Be Vietnam Pro" pitchFamily="34" charset="-122"/>
                 <a:cs typeface="Be Vietnam Pro" pitchFamily="34" charset="-120"/>
               </a:rPr>
-              <a:t> dài hơn</a:t>
-            </a:r>
-            <a:r>
-              <a:rPr lang="en-US" sz="1800" dirty="0" spc="-7" kern="0">
+              <a:t> thẻ</a:t>
+            </a:r>
+            <a:r>
+              <a:rPr lang="en-US" sz="1800" dirty="0" spc="-11" kern="0">
                 <a:solidFill>
                   <a:srgbClr val="D8D3C4"/>
                 </a:solidFill>
@@ -5072,10 +5094,10 @@
                 <a:ea typeface="Be Vietnam Pro" pitchFamily="34" charset="-122"/>
                 <a:cs typeface="Be Vietnam Pro" pitchFamily="34" charset="-120"/>
               </a:rPr>
-              <a:t> một</a:t>
-            </a:r>
-            <a:r>
-              <a:rPr lang="en-US" sz="1800" dirty="0" spc="0" kern="0">
+              <a:t> xác</a:t>
+            </a:r>
+            <a:r>
+              <a:rPr lang="en-US" sz="1800" dirty="0" spc="5" kern="0">
                 <a:solidFill>
                   <a:srgbClr val="D8D3C4"/>
                 </a:solidFill>
@@ -5083,7 +5105,7 @@
                 <a:ea typeface="Be Vietnam Pro" pitchFamily="34" charset="-122"/>
                 <a:cs typeface="Be Vietnam Pro" pitchFamily="34" charset="-120"/>
               </a:rPr>
-              <a:t> khối.</a:t>
+              <a:t> thực.</a:t>
             </a:r>
             <a:endParaRPr lang="en-US" sz="1800" dirty="0"/>
           </a:p>
@@ -11313,7 +11335,29 @@
                 <a:ea typeface="Be Vietnam Pro" pitchFamily="34" charset="-122"/>
                 <a:cs typeface="Be Vietnam Pro" pitchFamily="34" charset="-120"/>
               </a:rPr>
-              <a:t>mã</a:t>
+              <a:t>mã hóa,</a:t>
+            </a:r>
+            <a:r>
+              <a:rPr lang="en-US" sz="1800" dirty="0" spc="0" kern="0">
+                <a:solidFill>
+                  <a:srgbClr val="9A98A0"/>
+                </a:solidFill>
+                <a:latin typeface="Be Vietnam Pro" pitchFamily="34" charset="0"/>
+                <a:ea typeface="Be Vietnam Pro" pitchFamily="34" charset="-122"/>
+                <a:cs typeface="Be Vietnam Pro" pitchFamily="34" charset="-120"/>
+              </a:rPr>
+              <a:t> tự</a:t>
+            </a:r>
+            <a:r>
+              <a:rPr lang="en-US" sz="1800" dirty="0" spc="-12" kern="0">
+                <a:solidFill>
+                  <a:srgbClr val="9A98A0"/>
+                </a:solidFill>
+                <a:latin typeface="Be Vietnam Pro" pitchFamily="34" charset="0"/>
+                <a:ea typeface="Be Vietnam Pro" pitchFamily="34" charset="-122"/>
+                <a:cs typeface="Be Vietnam Pro" pitchFamily="34" charset="-120"/>
+              </a:rPr>
+              <a:t> gắn</a:t>
             </a:r>
             <a:r>
               <a:rPr lang="en-US" sz="1800" dirty="0" spc="-1" kern="0">
@@ -11324,10 +11368,10 @@
                 <a:ea typeface="Be Vietnam Pro" pitchFamily="34" charset="-122"/>
                 <a:cs typeface="Be Vietnam Pro" pitchFamily="34" charset="-120"/>
               </a:rPr>
-              <a:t> hóa</a:t>
-            </a:r>
-            <a:r>
-              <a:rPr lang="en-US" sz="1800" dirty="0" spc="0" kern="0">
+              <a:t> thẻ</a:t>
+            </a:r>
+            <a:r>
+              <a:rPr lang="en-US" sz="1800" dirty="0" spc="-11" kern="0">
                 <a:solidFill>
                   <a:srgbClr val="9A98A0"/>
                 </a:solidFill>
@@ -11335,10 +11379,10 @@
                 <a:ea typeface="Be Vietnam Pro" pitchFamily="34" charset="-122"/>
                 <a:cs typeface="Be Vietnam Pro" pitchFamily="34" charset="-120"/>
               </a:rPr>
-              <a:t> dữ</a:t>
-            </a:r>
-            <a:r>
-              <a:rPr lang="en-US" sz="1800" dirty="0" spc="-2" kern="0">
+              <a:t> xác</a:t>
+            </a:r>
+            <a:r>
+              <a:rPr lang="en-US" sz="1800" dirty="0" spc="6" kern="0">
                 <a:solidFill>
                   <a:srgbClr val="9A98A0"/>
                 </a:solidFill>
@@ -11346,7 +11390,7 @@
                 <a:ea typeface="Be Vietnam Pro" pitchFamily="34" charset="-122"/>
                 <a:cs typeface="Be Vietnam Pro" pitchFamily="34" charset="-120"/>
               </a:rPr>
-              <a:t> liệu</a:t>
+              <a:t> thực</a:t>
             </a:r>
             <a:endParaRPr lang="en-US" sz="1800" dirty="0"/>
           </a:p>
@@ -11451,10 +11495,10 @@
                 <a:ea typeface="Be Vietnam Pro" pitchFamily="34" charset="-122"/>
                 <a:cs typeface="Be Vietnam Pro" pitchFamily="34" charset="-120"/>
               </a:rPr>
-              <a:t>mã</a:t>
-            </a:r>
-            <a:r>
-              <a:rPr lang="en-US" sz="1800" dirty="0" spc="-11" kern="0">
+              <a:t>hàm</a:t>
+            </a:r>
+            <a:r>
+              <a:rPr lang="en-US" sz="1800" dirty="0" spc="-3" kern="0">
                 <a:solidFill>
                   <a:srgbClr val="9A98A0"/>
                 </a:solidFill>
@@ -11462,10 +11506,10 @@
                 <a:ea typeface="Be Vietnam Pro" pitchFamily="34" charset="-122"/>
                 <a:cs typeface="Be Vietnam Pro" pitchFamily="34" charset="-120"/>
               </a:rPr>
-              <a:t> xác</a:t>
-            </a:r>
-            <a:r>
-              <a:rPr lang="en-US" sz="1800" dirty="0" spc="6" kern="0">
+              <a:t> băm</a:t>
+            </a:r>
+            <a:r>
+              <a:rPr lang="en-US" sz="1800" dirty="0" spc="-2" kern="0">
                 <a:solidFill>
                   <a:srgbClr val="9A98A0"/>
                 </a:solidFill>
@@ -11473,10 +11517,10 @@
                 <a:ea typeface="Be Vietnam Pro" pitchFamily="34" charset="-122"/>
                 <a:cs typeface="Be Vietnam Pro" pitchFamily="34" charset="-120"/>
               </a:rPr>
-              <a:t> thực</a:t>
-            </a:r>
-            <a:r>
-              <a:rPr lang="en-US" sz="1800" dirty="0" spc="-3" kern="0">
+              <a:t> dùng</a:t>
+            </a:r>
+            <a:r>
+              <a:rPr lang="en-US" sz="1800" dirty="0" spc="-13" kern="0">
                 <a:solidFill>
                   <a:srgbClr val="9A98A0"/>
                 </a:solidFill>
@@ -11484,10 +11528,10 @@
                 <a:ea typeface="Be Vietnam Pro" pitchFamily="34" charset="-122"/>
                 <a:cs typeface="Be Vietnam Pro" pitchFamily="34" charset="-120"/>
               </a:rPr>
-              <a:t> thông</a:t>
-            </a:r>
-            <a:r>
-              <a:rPr lang="en-US" sz="1800" dirty="0" spc="15" kern="0">
+              <a:t> trong</a:t>
+            </a:r>
+            <a:r>
+              <a:rPr lang="en-US" sz="1800" dirty="0" spc="-12" kern="0">
                 <a:solidFill>
                   <a:srgbClr val="9A98A0"/>
                 </a:solidFill>
@@ -11495,7 +11539,18 @@
                 <a:ea typeface="Be Vietnam Pro" pitchFamily="34" charset="-122"/>
                 <a:cs typeface="Be Vietnam Pro" pitchFamily="34" charset="-120"/>
               </a:rPr>
-              <a:t> điệp</a:t>
+              <a:t> bắt</a:t>
+            </a:r>
+            <a:r>
+              <a:rPr lang="en-US" sz="1800" dirty="0" spc="-15" kern="0">
+                <a:solidFill>
+                  <a:srgbClr val="9A98A0"/>
+                </a:solidFill>
+                <a:latin typeface="Be Vietnam Pro" pitchFamily="34" charset="0"/>
+                <a:ea typeface="Be Vietnam Pro" pitchFamily="34" charset="-122"/>
+                <a:cs typeface="Be Vietnam Pro" pitchFamily="34" charset="-120"/>
+              </a:rPr>
+              <a:t> tay</a:t>
             </a:r>
             <a:endParaRPr lang="en-US" sz="1800" dirty="0"/>
           </a:p>
@@ -11521,6 +11576,213 @@
         <p:txBody>
           <a:bodyPr wrap="square" lIns="0" tIns="6858" rIns="0" bIns="-6858" rtlCol="0" anchor="t"/>
           <a:lstStyle/>
+          <a:p>
+            <a:pPr algn="l" indent="0" marL="0">
+              <a:lnSpc>
+                <a:spcPts val="2430"/>
+              </a:lnSpc>
+              <a:buNone/>
+            </a:pPr>
+            <a:r>
+              <a:rPr lang="en-US" sz="1800" dirty="0" spc="0" kern="0">
+                <a:solidFill>
+                  <a:srgbClr val="9A98A0"/>
+                </a:solidFill>
+                <a:latin typeface="Be Vietnam Pro" pitchFamily="34" charset="0"/>
+                <a:ea typeface="Be Vietnam Pro" pitchFamily="34" charset="-122"/>
+                <a:cs typeface="Be Vietnam Pro" pitchFamily="34" charset="-120"/>
+              </a:rPr>
+              <a:t>MDN</a:t>
+            </a:r>
+            <a:r>
+              <a:rPr lang="en-US" sz="1800" dirty="0" spc="9" kern="0">
+                <a:solidFill>
+                  <a:srgbClr val="9A98A0"/>
+                </a:solidFill>
+                <a:latin typeface="Be Vietnam Pro" pitchFamily="34" charset="0"/>
+                <a:ea typeface="Be Vietnam Pro" pitchFamily="34" charset="-122"/>
+                <a:cs typeface="Be Vietnam Pro" pitchFamily="34" charset="-120"/>
+              </a:rPr>
+              <a:t> đọc</a:t>
+            </a:r>
+            <a:r>
+              <a:rPr lang="en-US" sz="1800" dirty="0" spc="1" kern="0">
+                <a:solidFill>
+                  <a:srgbClr val="9A98A0"/>
+                </a:solidFill>
+                <a:latin typeface="Be Vietnam Pro" pitchFamily="34" charset="0"/>
+                <a:ea typeface="Be Vietnam Pro" pitchFamily="34" charset="-122"/>
+                <a:cs typeface="Be Vietnam Pro" pitchFamily="34" charset="-120"/>
+              </a:rPr>
+              <a:t> SHA256</a:t>
+            </a:r>
+            <a:r>
+              <a:rPr lang="en-US" sz="1800" dirty="0" spc="-2" kern="0">
+                <a:solidFill>
+                  <a:srgbClr val="9A98A0"/>
+                </a:solidFill>
+                <a:latin typeface="Be Vietnam Pro" pitchFamily="34" charset="0"/>
+                <a:ea typeface="Be Vietnam Pro" pitchFamily="34" charset="-122"/>
+                <a:cs typeface="Be Vietnam Pro" pitchFamily="34" charset="-120"/>
+              </a:rPr>
+              <a:t> là</a:t>
+            </a:r>
+            <a:r>
+              <a:rPr lang="en-US" sz="1800" dirty="0" spc="-1" kern="0">
+                <a:solidFill>
+                  <a:srgbClr val="9A98A0"/>
+                </a:solidFill>
+                <a:latin typeface="Be Vietnam Pro" pitchFamily="34" charset="0"/>
+                <a:ea typeface="Be Vietnam Pro" pitchFamily="34" charset="-122"/>
+                <a:cs typeface="Be Vietnam Pro" pitchFamily="34" charset="-120"/>
+              </a:rPr>
+              <a:t> mã</a:t>
+            </a:r>
+            <a:r>
+              <a:rPr lang="en-US" sz="1800" dirty="0" spc="-10" kern="0">
+                <a:solidFill>
+                  <a:srgbClr val="9A98A0"/>
+                </a:solidFill>
+                <a:latin typeface="Be Vietnam Pro" pitchFamily="34" charset="0"/>
+                <a:ea typeface="Be Vietnam Pro" pitchFamily="34" charset="-122"/>
+                <a:cs typeface="Be Vietnam Pro" pitchFamily="34" charset="-120"/>
+              </a:rPr>
+              <a:t> xác</a:t>
+            </a:r>
+            <a:r>
+              <a:rPr lang="en-US" sz="1800" dirty="0" spc="5" kern="0">
+                <a:solidFill>
+                  <a:srgbClr val="9A98A0"/>
+                </a:solidFill>
+                <a:latin typeface="Be Vietnam Pro" pitchFamily="34" charset="0"/>
+                <a:ea typeface="Be Vietnam Pro" pitchFamily="34" charset="-122"/>
+                <a:cs typeface="Be Vietnam Pro" pitchFamily="34" charset="-120"/>
+              </a:rPr>
+              <a:t> thực.</a:t>
+            </a:r>
+            <a:r>
+              <a:rPr lang="en-US" sz="1800" dirty="0" spc="-22" kern="0">
+                <a:solidFill>
+                  <a:srgbClr val="9A98A0"/>
+                </a:solidFill>
+                <a:latin typeface="Be Vietnam Pro" pitchFamily="34" charset="0"/>
+                <a:ea typeface="Be Vietnam Pro" pitchFamily="34" charset="-122"/>
+                <a:cs typeface="Be Vietnam Pro" pitchFamily="34" charset="-120"/>
+              </a:rPr>
+              <a:t> Với</a:t>
+            </a:r>
+            <a:r>
+              <a:rPr lang="en-US" sz="1800" dirty="0" spc="-3" kern="0">
+                <a:solidFill>
+                  <a:srgbClr val="9A98A0"/>
+                </a:solidFill>
+                <a:latin typeface="Be Vietnam Pro" pitchFamily="34" charset="0"/>
+                <a:ea typeface="Be Vietnam Pro" pitchFamily="34" charset="-122"/>
+                <a:cs typeface="Be Vietnam Pro" pitchFamily="34" charset="-120"/>
+              </a:rPr>
+              <a:t> bộ GCM,</a:t>
+            </a:r>
+            <a:r>
+              <a:rPr lang="en-US" sz="1800" dirty="0" spc="-1" kern="0">
+                <a:solidFill>
+                  <a:srgbClr val="9A98A0"/>
+                </a:solidFill>
+                <a:latin typeface="Be Vietnam Pro" pitchFamily="34" charset="0"/>
+                <a:ea typeface="Be Vietnam Pro" pitchFamily="34" charset="-122"/>
+                <a:cs typeface="Be Vietnam Pro" pitchFamily="34" charset="-120"/>
+              </a:rPr>
+              <a:t> thẻ</a:t>
+            </a:r>
+            <a:r>
+              <a:rPr lang="en-US" sz="1800" dirty="0" spc="-11" kern="0">
+                <a:solidFill>
+                  <a:srgbClr val="9A98A0"/>
+                </a:solidFill>
+                <a:latin typeface="Be Vietnam Pro" pitchFamily="34" charset="0"/>
+                <a:ea typeface="Be Vietnam Pro" pitchFamily="34" charset="-122"/>
+                <a:cs typeface="Be Vietnam Pro" pitchFamily="34" charset="-120"/>
+              </a:rPr>
+              <a:t> xác</a:t>
+            </a:r>
+            <a:r>
+              <a:rPr lang="en-US" sz="1800" dirty="0" spc="6" kern="0">
+                <a:solidFill>
+                  <a:srgbClr val="9A98A0"/>
+                </a:solidFill>
+                <a:latin typeface="Be Vietnam Pro" pitchFamily="34" charset="0"/>
+                <a:ea typeface="Be Vietnam Pro" pitchFamily="34" charset="-122"/>
+                <a:cs typeface="Be Vietnam Pro" pitchFamily="34" charset="-120"/>
+              </a:rPr>
+              <a:t> thực</a:t>
+            </a:r>
+            <a:r>
+              <a:rPr lang="en-US" sz="1800" dirty="0" spc="7" kern="0">
+                <a:solidFill>
+                  <a:srgbClr val="9A98A0"/>
+                </a:solidFill>
+                <a:latin typeface="Be Vietnam Pro" pitchFamily="34" charset="0"/>
+                <a:ea typeface="Be Vietnam Pro" pitchFamily="34" charset="-122"/>
+                <a:cs typeface="Be Vietnam Pro" pitchFamily="34" charset="-120"/>
+              </a:rPr>
+              <a:t> đến</a:t>
+            </a:r>
+            <a:r>
+              <a:rPr lang="en-US" sz="1800" dirty="0" spc="0" kern="0">
+                <a:solidFill>
+                  <a:srgbClr val="9A98A0"/>
+                </a:solidFill>
+                <a:latin typeface="Be Vietnam Pro" pitchFamily="34" charset="0"/>
+                <a:ea typeface="Be Vietnam Pro" pitchFamily="34" charset="-122"/>
+                <a:cs typeface="Be Vietnam Pro" pitchFamily="34" charset="-120"/>
+              </a:rPr>
+              <a:t> từ</a:t>
+            </a:r>
+            <a:r>
+              <a:rPr lang="en-US" sz="1800" dirty="0" spc="-3" kern="0">
+                <a:solidFill>
+                  <a:srgbClr val="9A98A0"/>
+                </a:solidFill>
+                <a:latin typeface="Be Vietnam Pro" pitchFamily="34" charset="0"/>
+                <a:ea typeface="Be Vietnam Pro" pitchFamily="34" charset="-122"/>
+                <a:cs typeface="Be Vietnam Pro" pitchFamily="34" charset="-120"/>
+              </a:rPr>
+              <a:t> GCM,</a:t>
+            </a:r>
+            <a:r>
+              <a:rPr lang="en-US" sz="1800" dirty="0" spc="-2" kern="0">
+                <a:solidFill>
+                  <a:srgbClr val="9A98A0"/>
+                </a:solidFill>
+                <a:latin typeface="Be Vietnam Pro" pitchFamily="34" charset="0"/>
+                <a:ea typeface="Be Vietnam Pro" pitchFamily="34" charset="-122"/>
+                <a:cs typeface="Be Vietnam Pro" pitchFamily="34" charset="-120"/>
+              </a:rPr>
+              <a:t> không</a:t>
+            </a:r>
+            <a:r>
+              <a:rPr lang="en-US" sz="1800" dirty="0" spc="0" kern="0">
+                <a:solidFill>
+                  <a:srgbClr val="9A98A0"/>
+                </a:solidFill>
+                <a:latin typeface="Be Vietnam Pro" pitchFamily="34" charset="0"/>
+                <a:ea typeface="Be Vietnam Pro" pitchFamily="34" charset="-122"/>
+                <a:cs typeface="Be Vietnam Pro" pitchFamily="34" charset="-120"/>
+              </a:rPr>
+              <a:t> phải từ</a:t>
+            </a:r>
+            <a:r>
+              <a:rPr lang="en-US" sz="1800" dirty="0" spc="1" kern="0">
+                <a:solidFill>
+                  <a:srgbClr val="9A98A0"/>
+                </a:solidFill>
+                <a:latin typeface="Be Vietnam Pro" pitchFamily="34" charset="0"/>
+                <a:ea typeface="Be Vietnam Pro" pitchFamily="34" charset="-122"/>
+                <a:cs typeface="Be Vietnam Pro" pitchFamily="34" charset="-120"/>
+              </a:rPr>
+              <a:t> SHA256.</a:t>
+            </a:r>
+            <a:endParaRPr lang="en-US" sz="1800" dirty="0"/>
+          </a:p>
           <a:p>
             <a:pPr algn="l" indent="0" marL="0">
               <a:lnSpc>

</xml_diff>

<commit_message>
System Design vi: sd-14-032, 034, 035 review fixes (directional TLS keys, HMAC wording, scope of the four token checks) and their decks
Co-Authored-By: Claude Sonnet 5.5 <noreply@anthropic.com>
Claude-Session: https://claude.ai/code/session_01WnjciXNJBLEd8jy3HrG49S
</commit_message>
<xml_diff>
--- a/system-design-101/vi/lessons/sd-14-032/slides/sd-14-032.pptx
+++ b/system-design-101/vi/lessons/sd-14-032/slides/sd-14-032.pptx
@@ -8645,7 +8645,7 @@
         <p:spPr>
           <a:xfrm>
             <a:off x="10267950" y="2819400"/>
-            <a:ext cx="6762750" cy="2095500"/>
+            <a:ext cx="6762750" cy="1143000"/>
           </a:xfrm>
           <a:prstGeom prst="rect">
             <a:avLst/>
@@ -8705,10 +8705,10 @@
                 <a:ea typeface="Be Vietnam Pro" pitchFamily="34" charset="-122"/>
                 <a:cs typeface="Be Vietnam Pro" pitchFamily="34" charset="-120"/>
               </a:rPr>
-              <a:t> tính</a:t>
-            </a:r>
-            <a:r>
-              <a:rPr lang="en-US" sz="3000" dirty="0" spc="-39" kern="0">
+              <a:t> tính khóa</a:t>
+            </a:r>
+            <a:r>
+              <a:rPr lang="en-US" sz="3000" dirty="0" spc="18" kern="0">
                 <a:solidFill>
                   <a:srgbClr val="FBF8F2"/>
                 </a:solidFill>
@@ -8716,10 +8716,10 @@
                 <a:ea typeface="Be Vietnam Pro" pitchFamily="34" charset="-122"/>
                 <a:cs typeface="Be Vietnam Pro" pitchFamily="34" charset="-120"/>
               </a:rPr>
-              <a:t> ra</a:t>
-            </a:r>
-            <a:r>
-              <a:rPr lang="en-US" sz="3000" dirty="0" spc="-5" kern="0">
+              <a:t> đối</a:t>
+            </a:r>
+            <a:r>
+              <a:rPr lang="en-US" sz="3000" dirty="0" spc="24" kern="0">
                 <a:solidFill>
                   <a:srgbClr val="FBF8F2"/>
                 </a:solidFill>
@@ -8727,7 +8727,29 @@
                 <a:ea typeface="Be Vietnam Pro" pitchFamily="34" charset="-122"/>
                 <a:cs typeface="Be Vietnam Pro" pitchFamily="34" charset="-120"/>
               </a:rPr>
-              <a:t> một</a:t>
+              <a:t> xứng</a:t>
+            </a:r>
+            <a:r>
+              <a:rPr lang="en-US" sz="3000" dirty="0" spc="21" kern="0">
+                <a:solidFill>
+                  <a:srgbClr val="FBF8F2"/>
+                </a:solidFill>
+                <a:latin typeface="Be Vietnam Pro" pitchFamily="34" charset="0"/>
+                <a:ea typeface="Be Vietnam Pro" pitchFamily="34" charset="-122"/>
+                <a:cs typeface="Be Vietnam Pro" pitchFamily="34" charset="-120"/>
+              </a:rPr>
+              <a:t> để</a:t>
+            </a:r>
+            <a:r>
+              <a:rPr lang="en-US" sz="3000" dirty="0" spc="1" kern="0">
+                <a:solidFill>
+                  <a:srgbClr val="FBF8F2"/>
+                </a:solidFill>
+                <a:latin typeface="Be Vietnam Pro" pitchFamily="34" charset="0"/>
+                <a:ea typeface="Be Vietnam Pro" pitchFamily="34" charset="-122"/>
+                <a:cs typeface="Be Vietnam Pro" pitchFamily="34" charset="-120"/>
+              </a:rPr>
+              <a:t> mã</a:t>
             </a:r>
             <a:r>
               <a:rPr lang="en-US" sz="3000" dirty="0" spc="-1" kern="0">
@@ -8738,84 +8760,7 @@
                 <a:ea typeface="Be Vietnam Pro" pitchFamily="34" charset="-122"/>
                 <a:cs typeface="Be Vietnam Pro" pitchFamily="34" charset="-120"/>
               </a:rPr>
-              <a:t> khóa</a:t>
-            </a:r>
-            <a:r>
-              <a:rPr lang="en-US" sz="3000" dirty="0" spc="18" kern="0">
-                <a:solidFill>
-                  <a:srgbClr val="FBF8F2"/>
-                </a:solidFill>
-                <a:latin typeface="Be Vietnam Pro" pitchFamily="34" charset="0"/>
-                <a:ea typeface="Be Vietnam Pro" pitchFamily="34" charset="-122"/>
-                <a:cs typeface="Be Vietnam Pro" pitchFamily="34" charset="-120"/>
-              </a:rPr>
-              <a:t> đối</a:t>
-            </a:r>
-            <a:r>
-              <a:rPr lang="en-US" sz="3000" dirty="0" spc="24" kern="0">
-                <a:solidFill>
-                  <a:srgbClr val="FBF8F2"/>
-                </a:solidFill>
-                <a:latin typeface="Be Vietnam Pro" pitchFamily="34" charset="0"/>
-                <a:ea typeface="Be Vietnam Pro" pitchFamily="34" charset="-122"/>
-                <a:cs typeface="Be Vietnam Pro" pitchFamily="34" charset="-120"/>
-              </a:rPr>
-              <a:t> xứng</a:t>
-            </a:r>
-            <a:r>
-              <a:rPr lang="en-US" sz="3000" dirty="0" spc="21" kern="0">
-                <a:solidFill>
-                  <a:srgbClr val="FBF8F2"/>
-                </a:solidFill>
-                <a:latin typeface="Be Vietnam Pro" pitchFamily="34" charset="0"/>
-                <a:ea typeface="Be Vietnam Pro" pitchFamily="34" charset="-122"/>
-                <a:cs typeface="Be Vietnam Pro" pitchFamily="34" charset="-120"/>
-              </a:rPr>
-              <a:t> để</a:t>
-            </a:r>
-            <a:r>
-              <a:rPr lang="en-US" sz="3000" dirty="0" spc="1" kern="0">
-                <a:solidFill>
-                  <a:srgbClr val="FBF8F2"/>
-                </a:solidFill>
-                <a:latin typeface="Be Vietnam Pro" pitchFamily="34" charset="0"/>
-                <a:ea typeface="Be Vietnam Pro" pitchFamily="34" charset="-122"/>
-                <a:cs typeface="Be Vietnam Pro" pitchFamily="34" charset="-120"/>
-              </a:rPr>
-              <a:t> mã</a:t>
-            </a:r>
-            <a:r>
-              <a:rPr lang="en-US" sz="3000" dirty="0" spc="-1" kern="0">
-                <a:solidFill>
-                  <a:srgbClr val="FBF8F2"/>
-                </a:solidFill>
-                <a:latin typeface="Be Vietnam Pro" pitchFamily="34" charset="0"/>
-                <a:ea typeface="Be Vietnam Pro" pitchFamily="34" charset="-122"/>
-                <a:cs typeface="Be Vietnam Pro" pitchFamily="34" charset="-120"/>
-              </a:rPr>
-              <a:t> hóa</a:t>
-            </a:r>
-            <a:r>
-              <a:rPr lang="en-US" sz="3000" dirty="0" spc="2" kern="0">
-                <a:solidFill>
-                  <a:srgbClr val="FBF8F2"/>
-                </a:solidFill>
-                <a:latin typeface="Be Vietnam Pro" pitchFamily="34" charset="0"/>
-                <a:ea typeface="Be Vietnam Pro" pitchFamily="34" charset="-122"/>
-                <a:cs typeface="Be Vietnam Pro" pitchFamily="34" charset="-120"/>
-              </a:rPr>
-              <a:t> dữ liệu</a:t>
-            </a:r>
-            <a:r>
-              <a:rPr lang="en-US" sz="3000" dirty="0" spc="-1" kern="0">
-                <a:solidFill>
-                  <a:srgbClr val="FBF8F2"/>
-                </a:solidFill>
-                <a:latin typeface="Be Vietnam Pro" pitchFamily="34" charset="0"/>
-                <a:ea typeface="Be Vietnam Pro" pitchFamily="34" charset="-122"/>
-                <a:cs typeface="Be Vietnam Pro" pitchFamily="34" charset="-120"/>
-              </a:rPr>
-              <a:t> HTTP.</a:t>
+              <a:t> hóa HTTP.</a:t>
             </a:r>
             <a:endParaRPr lang="en-US" sz="3000" dirty="0"/>
           </a:p>
@@ -8823,14 +8768,203 @@
       </p:sp>
       <p:sp>
         <p:nvSpPr>
-          <p:cNvPr id="23" name="Text 21"/>
-          <p:cNvSpPr/>
-          <p:nvPr/>
-        </p:nvSpPr>
-        <p:spPr>
-          <a:xfrm>
-            <a:off x="10267950" y="5467350"/>
-            <a:ext cx="2476500" cy="323850"/>
+          <p:cNvPr id="23" name="Shape 21"/>
+          <p:cNvSpPr/>
+          <p:nvPr/>
+        </p:nvSpPr>
+        <p:spPr>
+          <a:xfrm>
+            <a:off x="10458450" y="5943600"/>
+            <a:ext cx="3048000" cy="952500"/>
+          </a:xfrm>
+          <a:prstGeom prst="roundRect">
+            <a:avLst>
+              <a:gd name="adj" fmla="val 22000"/>
+            </a:avLst>
+          </a:prstGeom>
+          <a:solidFill>
+            <a:srgbClr val="F3DFB8"/>
+          </a:solidFill>
+          <a:ln/>
+        </p:spPr>
+      </p:sp>
+      <p:sp>
+        <p:nvSpPr>
+          <p:cNvPr id="24" name="Text 22"/>
+          <p:cNvSpPr/>
+          <p:nvPr/>
+        </p:nvSpPr>
+        <p:spPr>
+          <a:xfrm>
+            <a:off x="10458450" y="5943600"/>
+            <a:ext cx="3048000" cy="952500"/>
+          </a:xfrm>
+          <a:prstGeom prst="rect">
+            <a:avLst/>
+          </a:prstGeom>
+          <a:noFill/>
+          <a:ln/>
+        </p:spPr>
+        <p:txBody>
+          <a:bodyPr wrap="square" lIns="0" tIns="0" rIns="0" bIns="0" rtlCol="0" anchor="ctr"/>
+          <a:lstStyle/>
+          <a:p>
+            <a:pPr algn="ctr" indent="0" marL="0">
+              <a:buNone/>
+            </a:pPr>
+            <a:r>
+              <a:rPr lang="en-US" sz="2550" b="1" dirty="0" spc="-5" kern="0">
+                <a:solidFill>
+                  <a:srgbClr val="B45309"/>
+                </a:solidFill>
+                <a:latin typeface="Be Vietnam Pro" pitchFamily="34" charset="0"/>
+                <a:ea typeface="Be Vietnam Pro" pitchFamily="34" charset="-122"/>
+                <a:cs typeface="Be Vietnam Pro" pitchFamily="34" charset="-120"/>
+              </a:rPr>
+              <a:t>khóa</a:t>
+            </a:r>
+            <a:endParaRPr lang="en-US" sz="2550" dirty="0"/>
+          </a:p>
+          <a:p>
+            <a:pPr algn="ctr" indent="0" marL="0">
+              <a:buNone/>
+            </a:pPr>
+            <a:r>
+              <a:rPr lang="en-US" sz="1950" dirty="0" spc="-3" kern="0">
+                <a:solidFill>
+                  <a:srgbClr val="B45309"/>
+                </a:solidFill>
+                <a:latin typeface="Be Vietnam Pro SemiBold" pitchFamily="34" charset="0"/>
+                <a:ea typeface="Be Vietnam Pro SemiBold" pitchFamily="34" charset="-122"/>
+                <a:cs typeface="Be Vietnam Pro SemiBold" pitchFamily="34" charset="-120"/>
+              </a:rPr>
+              <a:t>client</a:t>
+            </a:r>
+            <a:r>
+              <a:rPr lang="en-US" sz="1950" dirty="0" spc="37" kern="0">
+                <a:solidFill>
+                  <a:srgbClr val="B45309"/>
+                </a:solidFill>
+                <a:latin typeface="Be Vietnam Pro SemiBold" pitchFamily="34" charset="0"/>
+                <a:ea typeface="Be Vietnam Pro SemiBold" pitchFamily="34" charset="-122"/>
+                <a:cs typeface="Be Vietnam Pro SemiBold" pitchFamily="34" charset="-120"/>
+              </a:rPr>
+              <a:t> gửi</a:t>
+            </a:r>
+            <a:endParaRPr lang="en-US" sz="2550" dirty="0"/>
+          </a:p>
+        </p:txBody>
+      </p:sp>
+      <p:sp>
+        <p:nvSpPr>
+          <p:cNvPr id="25" name="Shape 23"/>
+          <p:cNvSpPr/>
+          <p:nvPr/>
+        </p:nvSpPr>
+        <p:spPr>
+          <a:xfrm>
+            <a:off x="13792200" y="5943600"/>
+            <a:ext cx="3048000" cy="952500"/>
+          </a:xfrm>
+          <a:prstGeom prst="roundRect">
+            <a:avLst>
+              <a:gd name="adj" fmla="val 22000"/>
+            </a:avLst>
+          </a:prstGeom>
+          <a:solidFill>
+            <a:srgbClr val="F3DFB8"/>
+          </a:solidFill>
+          <a:ln/>
+        </p:spPr>
+      </p:sp>
+      <p:sp>
+        <p:nvSpPr>
+          <p:cNvPr id="26" name="Text 24"/>
+          <p:cNvSpPr/>
+          <p:nvPr/>
+        </p:nvSpPr>
+        <p:spPr>
+          <a:xfrm>
+            <a:off x="13792200" y="5943600"/>
+            <a:ext cx="3048000" cy="952500"/>
+          </a:xfrm>
+          <a:prstGeom prst="rect">
+            <a:avLst/>
+          </a:prstGeom>
+          <a:noFill/>
+          <a:ln/>
+        </p:spPr>
+        <p:txBody>
+          <a:bodyPr wrap="square" lIns="0" tIns="0" rIns="0" bIns="0" rtlCol="0" anchor="ctr"/>
+          <a:lstStyle/>
+          <a:p>
+            <a:pPr algn="ctr" indent="0" marL="0">
+              <a:buNone/>
+            </a:pPr>
+            <a:r>
+              <a:rPr lang="en-US" sz="2550" b="1" dirty="0" spc="-5" kern="0">
+                <a:solidFill>
+                  <a:srgbClr val="B45309"/>
+                </a:solidFill>
+                <a:latin typeface="Be Vietnam Pro" pitchFamily="34" charset="0"/>
+                <a:ea typeface="Be Vietnam Pro" pitchFamily="34" charset="-122"/>
+                <a:cs typeface="Be Vietnam Pro" pitchFamily="34" charset="-120"/>
+              </a:rPr>
+              <a:t>khóa</a:t>
+            </a:r>
+            <a:endParaRPr lang="en-US" sz="2550" dirty="0"/>
+          </a:p>
+          <a:p>
+            <a:pPr algn="ctr" indent="0" marL="0">
+              <a:buNone/>
+            </a:pPr>
+            <a:r>
+              <a:rPr lang="en-US" sz="1950" dirty="0" spc="-11" kern="0">
+                <a:solidFill>
+                  <a:srgbClr val="B45309"/>
+                </a:solidFill>
+                <a:latin typeface="Be Vietnam Pro SemiBold" pitchFamily="34" charset="0"/>
+                <a:ea typeface="Be Vietnam Pro SemiBold" pitchFamily="34" charset="-122"/>
+                <a:cs typeface="Be Vietnam Pro SemiBold" pitchFamily="34" charset="-120"/>
+              </a:rPr>
+              <a:t>máy</a:t>
+            </a:r>
+            <a:r>
+              <a:rPr lang="en-US" sz="1950" dirty="0" spc="0" kern="0">
+                <a:solidFill>
+                  <a:srgbClr val="B45309"/>
+                </a:solidFill>
+                <a:latin typeface="Be Vietnam Pro SemiBold" pitchFamily="34" charset="0"/>
+                <a:ea typeface="Be Vietnam Pro SemiBold" pitchFamily="34" charset="-122"/>
+                <a:cs typeface="Be Vietnam Pro SemiBold" pitchFamily="34" charset="-120"/>
+              </a:rPr>
+              <a:t> chủ</a:t>
+            </a:r>
+            <a:r>
+              <a:rPr lang="en-US" sz="1950" dirty="0" spc="37" kern="0">
+                <a:solidFill>
+                  <a:srgbClr val="B45309"/>
+                </a:solidFill>
+                <a:latin typeface="Be Vietnam Pro SemiBold" pitchFamily="34" charset="0"/>
+                <a:ea typeface="Be Vietnam Pro SemiBold" pitchFamily="34" charset="-122"/>
+                <a:cs typeface="Be Vietnam Pro SemiBold" pitchFamily="34" charset="-120"/>
+              </a:rPr>
+              <a:t> gửi</a:t>
+            </a:r>
+            <a:endParaRPr lang="en-US" sz="2550" dirty="0"/>
+          </a:p>
+        </p:txBody>
+      </p:sp>
+      <p:sp>
+        <p:nvSpPr>
+          <p:cNvPr id="27" name="Text 25"/>
+          <p:cNvSpPr/>
+          <p:nvPr/>
+        </p:nvSpPr>
+        <p:spPr>
+          <a:xfrm>
+            <a:off x="10267950" y="7162800"/>
+            <a:ext cx="6762750" cy="381000"/>
           </a:xfrm>
           <a:prstGeom prst="rect">
             <a:avLst/>
@@ -8846,268 +8980,18 @@
               <a:buNone/>
             </a:pPr>
             <a:r>
-              <a:rPr lang="en-US" sz="1800" dirty="0" spc="-4" kern="0">
-                <a:solidFill>
-                  <a:srgbClr val="F3DFB8"/>
-                </a:solidFill>
-                <a:latin typeface="Be Vietnam Pro SemiBold" pitchFamily="34" charset="0"/>
-                <a:ea typeface="Be Vietnam Pro SemiBold" pitchFamily="34" charset="-122"/>
-                <a:cs typeface="Be Vietnam Pro SemiBold" pitchFamily="34" charset="-120"/>
-              </a:rPr>
-              <a:t>client</a:t>
-            </a:r>
-            <a:endParaRPr lang="en-US" sz="1800" dirty="0"/>
-          </a:p>
-        </p:txBody>
-      </p:sp>
-      <p:sp>
-        <p:nvSpPr>
-          <p:cNvPr id="24" name="Text 22"/>
-          <p:cNvSpPr/>
-          <p:nvPr/>
-        </p:nvSpPr>
-        <p:spPr>
-          <a:xfrm>
-            <a:off x="14420850" y="5467350"/>
-            <a:ext cx="2476500" cy="323850"/>
-          </a:xfrm>
-          <a:prstGeom prst="rect">
-            <a:avLst/>
-          </a:prstGeom>
-          <a:noFill/>
-          <a:ln/>
-        </p:spPr>
-        <p:txBody>
-          <a:bodyPr wrap="square" lIns="0" tIns="0" rIns="0" bIns="0" rtlCol="0" anchor="t"/>
-          <a:lstStyle/>
-          <a:p>
-            <a:pPr algn="ctr" indent="0" marL="0">
-              <a:buNone/>
-            </a:pPr>
-            <a:r>
-              <a:rPr lang="en-US" sz="1800" dirty="0" spc="-10" kern="0">
-                <a:solidFill>
-                  <a:srgbClr val="F3DFB8"/>
-                </a:solidFill>
-                <a:latin typeface="Be Vietnam Pro SemiBold" pitchFamily="34" charset="0"/>
-                <a:ea typeface="Be Vietnam Pro SemiBold" pitchFamily="34" charset="-122"/>
-                <a:cs typeface="Be Vietnam Pro SemiBold" pitchFamily="34" charset="-120"/>
-              </a:rPr>
-              <a:t>máy</a:t>
-            </a:r>
-            <a:r>
-              <a:rPr lang="en-US" sz="1800" dirty="0" spc="2" kern="0">
-                <a:solidFill>
-                  <a:srgbClr val="F3DFB8"/>
-                </a:solidFill>
-                <a:latin typeface="Be Vietnam Pro SemiBold" pitchFamily="34" charset="0"/>
-                <a:ea typeface="Be Vietnam Pro SemiBold" pitchFamily="34" charset="-122"/>
-                <a:cs typeface="Be Vietnam Pro SemiBold" pitchFamily="34" charset="-120"/>
-              </a:rPr>
-              <a:t> chủ</a:t>
-            </a:r>
-            <a:endParaRPr lang="en-US" sz="1800" dirty="0"/>
-          </a:p>
-        </p:txBody>
-      </p:sp>
-      <p:sp>
-        <p:nvSpPr>
-          <p:cNvPr id="25" name="Shape 23"/>
-          <p:cNvSpPr/>
-          <p:nvPr/>
-        </p:nvSpPr>
-        <p:spPr>
-          <a:xfrm>
-            <a:off x="10458450" y="5943600"/>
-            <a:ext cx="2133600" cy="952500"/>
-          </a:xfrm>
-          <a:prstGeom prst="roundRect">
-            <a:avLst>
-              <a:gd name="adj" fmla="val 22000"/>
-            </a:avLst>
-          </a:prstGeom>
-          <a:solidFill>
-            <a:srgbClr val="F3DFB8"/>
-          </a:solidFill>
-          <a:ln/>
-        </p:spPr>
-      </p:sp>
-      <p:sp>
-        <p:nvSpPr>
-          <p:cNvPr id="26" name="Text 24"/>
-          <p:cNvSpPr/>
-          <p:nvPr/>
-        </p:nvSpPr>
-        <p:spPr>
-          <a:xfrm>
-            <a:off x="10458450" y="5943600"/>
-            <a:ext cx="2133600" cy="952500"/>
-          </a:xfrm>
-          <a:prstGeom prst="rect">
-            <a:avLst/>
-          </a:prstGeom>
-          <a:noFill/>
-          <a:ln/>
-        </p:spPr>
-        <p:txBody>
-          <a:bodyPr wrap="square" lIns="0" tIns="0" rIns="0" bIns="0" rtlCol="0" anchor="ctr"/>
-          <a:lstStyle/>
-          <a:p>
-            <a:pPr algn="ctr" indent="0" marL="0">
-              <a:buNone/>
-            </a:pPr>
-            <a:r>
-              <a:rPr lang="en-US" sz="2700" b="1" dirty="0" spc="-4" kern="0">
-                <a:solidFill>
-                  <a:srgbClr val="B45309"/>
-                </a:solidFill>
-                <a:latin typeface="Be Vietnam Pro" pitchFamily="34" charset="0"/>
-                <a:ea typeface="Be Vietnam Pro" pitchFamily="34" charset="-122"/>
-                <a:cs typeface="Be Vietnam Pro" pitchFamily="34" charset="-120"/>
-              </a:rPr>
-              <a:t>khóa</a:t>
-            </a:r>
-            <a:endParaRPr lang="en-US" sz="2700" dirty="0"/>
-          </a:p>
-        </p:txBody>
-      </p:sp>
-      <p:sp>
-        <p:nvSpPr>
-          <p:cNvPr id="27" name="Shape 25"/>
-          <p:cNvSpPr/>
-          <p:nvPr/>
-        </p:nvSpPr>
-        <p:spPr>
-          <a:xfrm>
-            <a:off x="14573250" y="5943600"/>
-            <a:ext cx="2133600" cy="952500"/>
-          </a:xfrm>
-          <a:prstGeom prst="roundRect">
-            <a:avLst>
-              <a:gd name="adj" fmla="val 22000"/>
-            </a:avLst>
-          </a:prstGeom>
-          <a:solidFill>
-            <a:srgbClr val="F3DFB8"/>
-          </a:solidFill>
-          <a:ln/>
-        </p:spPr>
-      </p:sp>
-      <p:sp>
-        <p:nvSpPr>
-          <p:cNvPr id="28" name="Text 26"/>
-          <p:cNvSpPr/>
-          <p:nvPr/>
-        </p:nvSpPr>
-        <p:spPr>
-          <a:xfrm>
-            <a:off x="14573250" y="5943600"/>
-            <a:ext cx="2133600" cy="952500"/>
-          </a:xfrm>
-          <a:prstGeom prst="rect">
-            <a:avLst/>
-          </a:prstGeom>
-          <a:noFill/>
-          <a:ln/>
-        </p:spPr>
-        <p:txBody>
-          <a:bodyPr wrap="square" lIns="0" tIns="0" rIns="0" bIns="0" rtlCol="0" anchor="ctr"/>
-          <a:lstStyle/>
-          <a:p>
-            <a:pPr algn="ctr" indent="0" marL="0">
-              <a:buNone/>
-            </a:pPr>
-            <a:r>
-              <a:rPr lang="en-US" sz="2700" b="1" dirty="0" spc="-4" kern="0">
-                <a:solidFill>
-                  <a:srgbClr val="B45309"/>
-                </a:solidFill>
-                <a:latin typeface="Be Vietnam Pro" pitchFamily="34" charset="0"/>
-                <a:ea typeface="Be Vietnam Pro" pitchFamily="34" charset="-122"/>
-                <a:cs typeface="Be Vietnam Pro" pitchFamily="34" charset="-120"/>
-              </a:rPr>
-              <a:t>khóa</a:t>
-            </a:r>
-            <a:endParaRPr lang="en-US" sz="2700" dirty="0"/>
-          </a:p>
-        </p:txBody>
-      </p:sp>
-      <p:sp>
-        <p:nvSpPr>
-          <p:cNvPr id="29" name="Text 27"/>
-          <p:cNvSpPr/>
-          <p:nvPr/>
-        </p:nvSpPr>
-        <p:spPr>
-          <a:xfrm>
-            <a:off x="12668250" y="5943600"/>
-            <a:ext cx="1828800" cy="952500"/>
-          </a:xfrm>
-          <a:prstGeom prst="rect">
-            <a:avLst/>
-          </a:prstGeom>
-          <a:noFill/>
-          <a:ln/>
-        </p:spPr>
-        <p:txBody>
-          <a:bodyPr wrap="square" lIns="0" tIns="0" rIns="0" bIns="0" rtlCol="0" anchor="ctr"/>
-          <a:lstStyle/>
-          <a:p>
-            <a:pPr algn="ctr" indent="0" marL="0">
-              <a:buNone/>
-            </a:pPr>
-            <a:r>
-              <a:rPr lang="en-US" sz="5400" dirty="0" spc="-1" kern="0">
+              <a:rPr lang="en-US" sz="2100" dirty="0" spc="0" kern="0">
                 <a:solidFill>
                   <a:srgbClr val="FBF8F2"/>
                 </a:solidFill>
-                <a:latin typeface="Bricolage Grotesque ExtraBold" pitchFamily="34" charset="0"/>
-                <a:ea typeface="Bricolage Grotesque ExtraBold" pitchFamily="34" charset="-122"/>
-                <a:cs typeface="Bricolage Grotesque ExtraBold" pitchFamily="34" charset="-120"/>
-              </a:rPr>
-              <a:t>=</a:t>
-            </a:r>
-            <a:endParaRPr lang="en-US" sz="5400" dirty="0"/>
-          </a:p>
-        </p:txBody>
-      </p:sp>
-      <p:sp>
-        <p:nvSpPr>
-          <p:cNvPr id="30" name="Text 28"/>
-          <p:cNvSpPr/>
-          <p:nvPr/>
-        </p:nvSpPr>
-        <p:spPr>
-          <a:xfrm>
-            <a:off x="10267950" y="7162800"/>
-            <a:ext cx="6762750" cy="381000"/>
-          </a:xfrm>
-          <a:prstGeom prst="rect">
-            <a:avLst/>
-          </a:prstGeom>
-          <a:noFill/>
-          <a:ln/>
-        </p:spPr>
-        <p:txBody>
-          <a:bodyPr wrap="square" lIns="0" tIns="0" rIns="0" bIns="0" rtlCol="0" anchor="t"/>
-          <a:lstStyle/>
-          <a:p>
-            <a:pPr algn="ctr" indent="0" marL="0">
-              <a:buNone/>
-            </a:pPr>
-            <a:r>
-              <a:rPr lang="en-US" sz="2100" dirty="0" spc="2" kern="0">
-                <a:solidFill>
-                  <a:srgbClr val="FBF8F2"/>
-                </a:solidFill>
-                <a:latin typeface="Be Vietnam Pro" pitchFamily="34" charset="0"/>
-                <a:ea typeface="Be Vietnam Pro" pitchFamily="34" charset="-122"/>
-                <a:cs typeface="Be Vietnam Pro" pitchFamily="34" charset="-120"/>
-              </a:rPr>
-              <a:t>cùng</a:t>
-            </a:r>
-            <a:r>
-              <a:rPr lang="en-US" sz="2100" dirty="0" spc="-8" kern="0">
+                <a:latin typeface="Be Vietnam Pro" pitchFamily="34" charset="0"/>
+                <a:ea typeface="Be Vietnam Pro" pitchFamily="34" charset="-122"/>
+                <a:cs typeface="Be Vietnam Pro" pitchFamily="34" charset="-120"/>
+              </a:rPr>
+              <a:t>mỗi chiều</a:t>
+            </a:r>
+            <a:r>
+              <a:rPr lang="en-US" sz="2100" dirty="0" spc="-7" kern="0">
                 <a:solidFill>
                   <a:srgbClr val="FBF8F2"/>
                 </a:solidFill>
@@ -9156,7 +9040,7 @@
       </p:sp>
       <p:sp>
         <p:nvSpPr>
-          <p:cNvPr id="31" name="Connector line-1792363621771-167175568"/>
+          <p:cNvPr id="28" name="Connector line-1792363621771-167175568"/>
           <p:cNvSpPr/>
           <p:nvPr/>
         </p:nvSpPr>
@@ -9183,7 +9067,7 @@
       </p:sp>
       <p:sp>
         <p:nvSpPr>
-          <p:cNvPr id="32" name="Text 30"/>
+          <p:cNvPr id="29" name="Text 27"/>
           <p:cNvSpPr/>
           <p:nvPr/>
         </p:nvSpPr>
@@ -9266,7 +9150,7 @@
       </p:sp>
       <p:sp>
         <p:nvSpPr>
-          <p:cNvPr id="33" name="Connector line-1792363621773-855857994"/>
+          <p:cNvPr id="30" name="Connector line-1792363621773-855857994"/>
           <p:cNvSpPr/>
           <p:nvPr/>
         </p:nvSpPr>
@@ -9293,7 +9177,7 @@
       </p:sp>
       <p:sp>
         <p:nvSpPr>
-          <p:cNvPr id="34" name="Shape 32"/>
+          <p:cNvPr id="31" name="Shape 29"/>
           <p:cNvSpPr/>
           <p:nvPr/>
         </p:nvSpPr>
@@ -9313,7 +9197,7 @@
       </p:sp>
       <p:sp>
         <p:nvSpPr>
-          <p:cNvPr id="35" name="Shape 33"/>
+          <p:cNvPr id="32" name="Shape 30"/>
           <p:cNvSpPr/>
           <p:nvPr/>
         </p:nvSpPr>
@@ -9333,7 +9217,7 @@
       </p:sp>
       <p:sp>
         <p:nvSpPr>
-          <p:cNvPr id="36" name="Shape 34"/>
+          <p:cNvPr id="33" name="Shape 31"/>
           <p:cNvSpPr/>
           <p:nvPr/>
         </p:nvSpPr>
@@ -9358,7 +9242,7 @@
       </p:sp>
       <p:sp>
         <p:nvSpPr>
-          <p:cNvPr id="37" name="Shape 35"/>
+          <p:cNvPr id="34" name="Shape 32"/>
           <p:cNvSpPr/>
           <p:nvPr/>
         </p:nvSpPr>
@@ -9383,7 +9267,7 @@
       </p:sp>
       <p:sp>
         <p:nvSpPr>
-          <p:cNvPr id="38" name="Shape 36"/>
+          <p:cNvPr id="35" name="Shape 33"/>
           <p:cNvSpPr/>
           <p:nvPr/>
         </p:nvSpPr>
@@ -9408,7 +9292,7 @@
       </p:sp>
       <p:sp>
         <p:nvSpPr>
-          <p:cNvPr id="39" name="Shape 37"/>
+          <p:cNvPr id="36" name="Shape 34"/>
           <p:cNvSpPr/>
           <p:nvPr/>
         </p:nvSpPr>
@@ -9433,7 +9317,7 @@
       </p:sp>
       <p:sp>
         <p:nvSpPr>
-          <p:cNvPr id="40" name="Shape 38"/>
+          <p:cNvPr id="37" name="Shape 35"/>
           <p:cNvSpPr/>
           <p:nvPr/>
         </p:nvSpPr>
@@ -9458,7 +9342,7 @@
       </p:sp>
       <p:sp>
         <p:nvSpPr>
-          <p:cNvPr id="41" name="Shape 39"/>
+          <p:cNvPr id="38" name="Shape 36"/>
           <p:cNvSpPr/>
           <p:nvPr/>
         </p:nvSpPr>
@@ -9483,7 +9367,7 @@
       </p:sp>
       <p:sp>
         <p:nvSpPr>
-          <p:cNvPr id="42" name="Shape 40"/>
+          <p:cNvPr id="39" name="Shape 37"/>
           <p:cNvSpPr/>
           <p:nvPr/>
         </p:nvSpPr>
@@ -9508,7 +9392,7 @@
       </p:sp>
       <p:sp>
         <p:nvSpPr>
-          <p:cNvPr id="43" name="Shape 41"/>
+          <p:cNvPr id="40" name="Shape 38"/>
           <p:cNvSpPr/>
           <p:nvPr/>
         </p:nvSpPr>
@@ -9533,7 +9417,7 @@
       </p:sp>
       <p:sp>
         <p:nvSpPr>
-          <p:cNvPr id="44" name="Text 42"/>
+          <p:cNvPr id="41" name="Text 39"/>
           <p:cNvSpPr/>
           <p:nvPr/>
         </p:nvSpPr>
@@ -9646,6 +9530,135 @@
             <a:endParaRPr lang="en-US" sz="1650" dirty="0"/>
           </a:p>
         </p:txBody>
+      </p:sp>
+      <p:sp>
+        <p:nvSpPr>
+          <p:cNvPr id="42" name="Text 40"/>
+          <p:cNvSpPr/>
+          <p:nvPr/>
+        </p:nvSpPr>
+        <p:spPr>
+          <a:xfrm>
+            <a:off x="11410950" y="4362450"/>
+            <a:ext cx="4476750" cy="800100"/>
+          </a:xfrm>
+          <a:prstGeom prst="roundRect">
+            <a:avLst>
+              <a:gd name="adj" fmla="val 26190"/>
+            </a:avLst>
+          </a:prstGeom>
+          <a:noFill/>
+          <a:ln w="28575">
+            <a:solidFill>
+              <a:srgbClr val="F3DFB8"/>
+            </a:solidFill>
+            <a:prstDash val="solid"/>
+          </a:ln>
+        </p:spPr>
+        <p:txBody>
+          <a:bodyPr wrap="square" lIns="0" tIns="0" rIns="0" bIns="0" rtlCol="0" anchor="ctr"/>
+          <a:lstStyle/>
+          <a:p>
+            <a:pPr algn="ctr" indent="0" marL="0">
+              <a:buNone/>
+            </a:pPr>
+            <a:r>
+              <a:rPr lang="en-US" sz="2550" b="1" dirty="0" spc="-12" kern="0">
+                <a:solidFill>
+                  <a:srgbClr val="FBF8F2"/>
+                </a:solidFill>
+                <a:latin typeface="Be Vietnam Pro" pitchFamily="34" charset="0"/>
+                <a:ea typeface="Be Vietnam Pro" pitchFamily="34" charset="-122"/>
+                <a:cs typeface="Be Vietnam Pro" pitchFamily="34" charset="-120"/>
+              </a:rPr>
+              <a:t>một</a:t>
+            </a:r>
+            <a:r>
+              <a:rPr lang="en-US" sz="2550" b="1" dirty="0" spc="-1" kern="0">
+                <a:solidFill>
+                  <a:srgbClr val="FBF8F2"/>
+                </a:solidFill>
+                <a:latin typeface="Be Vietnam Pro" pitchFamily="34" charset="0"/>
+                <a:ea typeface="Be Vietnam Pro" pitchFamily="34" charset="-122"/>
+                <a:cs typeface="Be Vietnam Pro" pitchFamily="34" charset="-120"/>
+              </a:rPr>
+              <a:t> bí</a:t>
+            </a:r>
+            <a:r>
+              <a:rPr lang="en-US" sz="2550" b="1" dirty="0" spc="-8" kern="0">
+                <a:solidFill>
+                  <a:srgbClr val="FBF8F2"/>
+                </a:solidFill>
+                <a:latin typeface="Be Vietnam Pro" pitchFamily="34" charset="0"/>
+                <a:ea typeface="Be Vietnam Pro" pitchFamily="34" charset="-122"/>
+                <a:cs typeface="Be Vietnam Pro" pitchFamily="34" charset="-120"/>
+              </a:rPr>
+              <a:t> mật</a:t>
+            </a:r>
+            <a:r>
+              <a:rPr lang="en-US" sz="2550" b="1" dirty="0" spc="-1" kern="0">
+                <a:solidFill>
+                  <a:srgbClr val="FBF8F2"/>
+                </a:solidFill>
+                <a:latin typeface="Be Vietnam Pro" pitchFamily="34" charset="0"/>
+                <a:ea typeface="Be Vietnam Pro" pitchFamily="34" charset="-122"/>
+                <a:cs typeface="Be Vietnam Pro" pitchFamily="34" charset="-120"/>
+              </a:rPr>
+              <a:t> chung</a:t>
+            </a:r>
+            <a:endParaRPr lang="en-US" sz="2550" dirty="0"/>
+          </a:p>
+        </p:txBody>
+      </p:sp>
+      <p:sp>
+        <p:nvSpPr>
+          <p:cNvPr id="43" name="Connector line-1792383655362-574344358"/>
+          <p:cNvSpPr/>
+          <p:nvPr/>
+        </p:nvSpPr>
+        <p:spPr>
+          <a:xfrm flipH="1">
+            <a:off x="11982450" y="5200650"/>
+            <a:ext cx="876300" cy="647700"/>
+          </a:xfrm>
+          <a:prstGeom prst="line">
+            <a:avLst/>
+          </a:prstGeom>
+          <a:noFill/>
+          <a:ln w="38100">
+            <a:solidFill>
+              <a:srgbClr val="F3DFB8"/>
+            </a:solidFill>
+            <a:prstDash val="solid"/>
+            <a:headEnd type="none"/>
+            <a:tailEnd type="triangle" w="lg" len="lg"/>
+          </a:ln>
+        </p:spPr>
+      </p:sp>
+      <p:sp>
+        <p:nvSpPr>
+          <p:cNvPr id="44" name="Connector line-1792383655363-301854782"/>
+          <p:cNvSpPr/>
+          <p:nvPr/>
+        </p:nvSpPr>
+        <p:spPr>
+          <a:xfrm>
+            <a:off x="14439900" y="5200650"/>
+            <a:ext cx="876300" cy="647700"/>
+          </a:xfrm>
+          <a:prstGeom prst="line">
+            <a:avLst/>
+          </a:prstGeom>
+          <a:noFill/>
+          <a:ln w="38100">
+            <a:solidFill>
+              <a:srgbClr val="F3DFB8"/>
+            </a:solidFill>
+            <a:prstDash val="solid"/>
+            <a:headEnd type="none"/>
+            <a:tailEnd type="triangle" w="lg" len="lg"/>
+          </a:ln>
+        </p:spPr>
       </p:sp>
       <p:sp>
         <p:nvSpPr>

</xml_diff>

<commit_message>
System Design vi: sd-14-032 deck scopes the negotiation hook to a full handshake
Co-Authored-By: Claude Sonnet 5.5 <noreply@anthropic.com>
Claude-Session: https://claude.ai/code/session_01WnjciXNJBLEd8jy3HrG49S
</commit_message>
<xml_diff>
--- a/system-design-101/vi/lessons/sd-14-032/slides/sd-14-032.pptx
+++ b/system-design-101/vi/lessons/sd-14-032/slides/sd-14-032.pptx
@@ -2024,7 +2024,7 @@
               <a:buNone/>
             </a:pPr>
             <a:r>
-              <a:rPr lang="en-US" sz="2700" dirty="0" spc="-28" kern="0">
+              <a:rPr lang="en-US" sz="2700" dirty="0" spc="-39" kern="0">
                 <a:solidFill>
                   <a:srgbClr val="D8D3C4"/>
                 </a:solidFill>
@@ -2032,7 +2032,40 @@
                 <a:ea typeface="Be Vietnam Pro" pitchFamily="34" charset="-122"/>
                 <a:cs typeface="Be Vietnam Pro" pitchFamily="34" charset="-120"/>
               </a:rPr>
-              <a:t>Trước</a:t>
+              <a:t>Với</a:t>
+            </a:r>
+            <a:r>
+              <a:rPr lang="en-US" sz="2700" dirty="0" spc="-17" kern="0">
+                <a:solidFill>
+                  <a:srgbClr val="D8D3C4"/>
+                </a:solidFill>
+                <a:latin typeface="Be Vietnam Pro" pitchFamily="34" charset="0"/>
+                <a:ea typeface="Be Vietnam Pro" pitchFamily="34" charset="-122"/>
+                <a:cs typeface="Be Vietnam Pro" pitchFamily="34" charset="-120"/>
+              </a:rPr>
+              <a:t> bắt</a:t>
+            </a:r>
+            <a:r>
+              <a:rPr lang="en-US" sz="2700" dirty="0" spc="-24" kern="0">
+                <a:solidFill>
+                  <a:srgbClr val="D8D3C4"/>
+                </a:solidFill>
+                <a:latin typeface="Be Vietnam Pro" pitchFamily="34" charset="0"/>
+                <a:ea typeface="Be Vietnam Pro" pitchFamily="34" charset="-122"/>
+                <a:cs typeface="Be Vietnam Pro" pitchFamily="34" charset="-120"/>
+              </a:rPr>
+              <a:t> tay</a:t>
+            </a:r>
+            <a:r>
+              <a:rPr lang="en-US" sz="2700" dirty="0" spc="2" kern="0">
+                <a:solidFill>
+                  <a:srgbClr val="D8D3C4"/>
+                </a:solidFill>
+                <a:latin typeface="Be Vietnam Pro" pitchFamily="34" charset="0"/>
+                <a:ea typeface="Be Vietnam Pro" pitchFamily="34" charset="-122"/>
+                <a:cs typeface="Be Vietnam Pro" pitchFamily="34" charset="-120"/>
+              </a:rPr>
+              <a:t> đầy</a:t>
             </a:r>
             <a:r>
               <a:rPr lang="en-US" sz="2700" dirty="0" spc="-1" kern="0">
@@ -2043,10 +2076,32 @@
                 <a:ea typeface="Be Vietnam Pro" pitchFamily="34" charset="-122"/>
                 <a:cs typeface="Be Vietnam Pro" pitchFamily="34" charset="-120"/>
               </a:rPr>
+              <a:t> đủ,</a:t>
+            </a:r>
+            <a:r>
+              <a:rPr lang="en-US" sz="2700" dirty="0" spc="8" kern="0">
+                <a:solidFill>
+                  <a:srgbClr val="D8D3C4"/>
+                </a:solidFill>
+                <a:latin typeface="Be Vietnam Pro" pitchFamily="34" charset="0"/>
+                <a:ea typeface="Be Vietnam Pro" pitchFamily="34" charset="-122"/>
+                <a:cs typeface="Be Vietnam Pro" pitchFamily="34" charset="-120"/>
+              </a:rPr>
+              <a:t> trước</a:t>
+            </a:r>
+            <a:r>
+              <a:rPr lang="en-US" sz="2700" dirty="0" spc="-2" kern="0">
+                <a:solidFill>
+                  <a:srgbClr val="D8D3C4"/>
+                </a:solidFill>
+                <a:latin typeface="Be Vietnam Pro" pitchFamily="34" charset="0"/>
+                <a:ea typeface="Be Vietnam Pro" pitchFamily="34" charset="-122"/>
+                <a:cs typeface="Be Vietnam Pro" pitchFamily="34" charset="-120"/>
+              </a:rPr>
               <a:t> khi</a:t>
             </a:r>
             <a:r>
-              <a:rPr lang="en-US" sz="2700" dirty="0" spc="-2" kern="0">
+              <a:rPr lang="en-US" sz="2700" dirty="0" spc="-1" kern="0">
                 <a:solidFill>
                   <a:srgbClr val="D8D3C4"/>
                 </a:solidFill>
@@ -2068,6 +2123,50 @@
               <a:t> hóa</a:t>
             </a:r>
             <a:r>
+              <a:rPr lang="en-US" sz="2700" dirty="0" spc="-8" kern="0">
+                <a:solidFill>
+                  <a:srgbClr val="D8D3C4"/>
+                </a:solidFill>
+                <a:latin typeface="Be Vietnam Pro" pitchFamily="34" charset="0"/>
+                <a:ea typeface="Be Vietnam Pro" pitchFamily="34" charset="-122"/>
+                <a:cs typeface="Be Vietnam Pro" pitchFamily="34" charset="-120"/>
+              </a:rPr>
+              <a:t> một</a:t>
+            </a:r>
+            <a:r>
+              <a:rPr lang="en-US" sz="2700" dirty="0" spc="-18" kern="0">
+                <a:solidFill>
+                  <a:srgbClr val="D8D3C4"/>
+                </a:solidFill>
+                <a:latin typeface="Be Vietnam Pro" pitchFamily="34" charset="0"/>
+                <a:ea typeface="Be Vietnam Pro" pitchFamily="34" charset="-122"/>
+                <a:cs typeface="Be Vietnam Pro" pitchFamily="34" charset="-120"/>
+              </a:rPr>
+              <a:t> byte</a:t>
+            </a:r>
+            <a:r>
+              <a:rPr lang="en-US" sz="2700" dirty="0" spc="3" kern="0">
+                <a:solidFill>
+                  <a:srgbClr val="D8D3C4"/>
+                </a:solidFill>
+                <a:latin typeface="Be Vietnam Pro" pitchFamily="34" charset="0"/>
+                <a:ea typeface="Be Vietnam Pro" pitchFamily="34" charset="-122"/>
+                <a:cs typeface="Be Vietnam Pro" pitchFamily="34" charset="-120"/>
+              </a:rPr>
+              <a:t> HTTP,</a:t>
+            </a:r>
+            <a:r>
+              <a:rPr lang="en-US" sz="2700" dirty="0" spc="-3" kern="0">
+                <a:solidFill>
+                  <a:srgbClr val="D8D3C4"/>
+                </a:solidFill>
+                <a:latin typeface="Be Vietnam Pro" pitchFamily="34" charset="0"/>
+                <a:ea typeface="Be Vietnam Pro" pitchFamily="34" charset="-122"/>
+                <a:cs typeface="Be Vietnam Pro" pitchFamily="34" charset="-120"/>
+              </a:rPr>
+              <a:t> hai</a:t>
+            </a:r>
+            <a:r>
               <a:rPr lang="en-US" sz="2700" dirty="0" spc="-7" kern="0">
                 <a:solidFill>
                   <a:srgbClr val="D8D3C4"/>
@@ -2076,10 +2175,10 @@
                 <a:ea typeface="Be Vietnam Pro" pitchFamily="34" charset="-122"/>
                 <a:cs typeface="Be Vietnam Pro" pitchFamily="34" charset="-120"/>
               </a:rPr>
-              <a:t> một</a:t>
-            </a:r>
-            <a:r>
-              <a:rPr lang="en-US" sz="2700" dirty="0" spc="-19" kern="0">
+              <a:t> bên</a:t>
+            </a:r>
+            <a:r>
+              <a:rPr lang="en-US" sz="2700" dirty="0" spc="-1" kern="0">
                 <a:solidFill>
                   <a:srgbClr val="D8D3C4"/>
                 </a:solidFill>
@@ -2087,10 +2186,10 @@
                 <a:ea typeface="Be Vietnam Pro" pitchFamily="34" charset="-122"/>
                 <a:cs typeface="Be Vietnam Pro" pitchFamily="34" charset="-120"/>
               </a:rPr>
-              <a:t> byte</a:t>
-            </a:r>
-            <a:r>
-              <a:rPr lang="en-US" sz="2700" dirty="0" spc="3" kern="0">
+              <a:t> phải</a:t>
+            </a:r>
+            <a:r>
+              <a:rPr lang="en-US" sz="2700" dirty="0" spc="-4" kern="0">
                 <a:solidFill>
                   <a:srgbClr val="D8D3C4"/>
                 </a:solidFill>
@@ -2098,10 +2197,10 @@
                 <a:ea typeface="Be Vietnam Pro" pitchFamily="34" charset="-122"/>
                 <a:cs typeface="Be Vietnam Pro" pitchFamily="34" charset="-120"/>
               </a:rPr>
-              <a:t> HTTP,</a:t>
-            </a:r>
-            <a:r>
-              <a:rPr lang="en-US" sz="2700" dirty="0" spc="-2" kern="0">
+              <a:t> thỏa</a:t>
+            </a:r>
+            <a:r>
+              <a:rPr lang="en-US" sz="2700" dirty="0" spc="0" kern="0">
                 <a:solidFill>
                   <a:srgbClr val="D8D3C4"/>
                 </a:solidFill>
@@ -2109,10 +2208,10 @@
                 <a:ea typeface="Be Vietnam Pro" pitchFamily="34" charset="-122"/>
                 <a:cs typeface="Be Vietnam Pro" pitchFamily="34" charset="-120"/>
               </a:rPr>
-              <a:t> hai</a:t>
-            </a:r>
-            <a:r>
-              <a:rPr lang="en-US" sz="2700" dirty="0" spc="-8" kern="0">
+              <a:t> thuận</a:t>
+            </a:r>
+            <a:r>
+              <a:rPr lang="en-US" sz="2700" dirty="0" spc="2" kern="0">
                 <a:solidFill>
                   <a:srgbClr val="D8D3C4"/>
                 </a:solidFill>
@@ -2120,40 +2219,7 @@
                 <a:ea typeface="Be Vietnam Pro" pitchFamily="34" charset="-122"/>
                 <a:cs typeface="Be Vietnam Pro" pitchFamily="34" charset="-120"/>
               </a:rPr>
-              <a:t> bên</a:t>
-            </a:r>
-            <a:r>
-              <a:rPr lang="en-US" sz="2700" dirty="0" spc="-1" kern="0">
-                <a:solidFill>
-                  <a:srgbClr val="D8D3C4"/>
-                </a:solidFill>
-                <a:latin typeface="Be Vietnam Pro" pitchFamily="34" charset="0"/>
-                <a:ea typeface="Be Vietnam Pro" pitchFamily="34" charset="-122"/>
-                <a:cs typeface="Be Vietnam Pro" pitchFamily="34" charset="-120"/>
-              </a:rPr>
-              <a:t> phải</a:t>
-            </a:r>
-            <a:r>
-              <a:rPr lang="en-US" sz="2700" dirty="0" spc="-4" kern="0">
-                <a:solidFill>
-                  <a:srgbClr val="D8D3C4"/>
-                </a:solidFill>
-                <a:latin typeface="Be Vietnam Pro" pitchFamily="34" charset="0"/>
-                <a:ea typeface="Be Vietnam Pro" pitchFamily="34" charset="-122"/>
-                <a:cs typeface="Be Vietnam Pro" pitchFamily="34" charset="-120"/>
-              </a:rPr>
-              <a:t> thỏa</a:t>
-            </a:r>
-            <a:r>
-              <a:rPr lang="en-US" sz="2700" dirty="0" spc="1" kern="0">
-                <a:solidFill>
-                  <a:srgbClr val="D8D3C4"/>
-                </a:solidFill>
-                <a:latin typeface="Be Vietnam Pro" pitchFamily="34" charset="0"/>
-                <a:ea typeface="Be Vietnam Pro" pitchFamily="34" charset="-122"/>
-                <a:cs typeface="Be Vietnam Pro" pitchFamily="34" charset="-120"/>
-              </a:rPr>
-              <a:t> thuận cách</a:t>
+              <a:t> cách</a:t>
             </a:r>
             <a:r>
               <a:rPr lang="en-US" sz="2700" dirty="0" spc="-2" kern="0">
@@ -8280,7 +8346,7 @@
         <p:spPr>
           <a:xfrm>
             <a:off x="914400" y="8058150"/>
-            <a:ext cx="8382000" cy="762000"/>
+            <a:ext cx="8382000" cy="1104900"/>
           </a:xfrm>
           <a:prstGeom prst="rect">
             <a:avLst/>
@@ -8495,6 +8561,125 @@
                 <a:cs typeface="Be Vietnam Pro" pitchFamily="34" charset="-120"/>
               </a:rPr>
               <a:t> viết.</a:t>
+            </a:r>
+            <a:endParaRPr lang="en-US" sz="1800" dirty="0"/>
+          </a:p>
+          <a:p>
+            <a:pPr algn="l" indent="0" marL="0">
+              <a:lnSpc>
+                <a:spcPts val="2430"/>
+              </a:lnSpc>
+              <a:buNone/>
+            </a:pPr>
+            <a:r>
+              <a:rPr lang="en-US" sz="1800" dirty="0" spc="-8" kern="0">
+                <a:solidFill>
+                  <a:srgbClr val="6B6A66"/>
+                </a:solidFill>
+                <a:latin typeface="Be Vietnam Pro" pitchFamily="34" charset="0"/>
+                <a:ea typeface="Be Vietnam Pro" pitchFamily="34" charset="-122"/>
+                <a:cs typeface="Be Vietnam Pro" pitchFamily="34" charset="-120"/>
+              </a:rPr>
+              <a:t>Ngoại</a:t>
+            </a:r>
+            <a:r>
+              <a:rPr lang="en-US" sz="1800" dirty="0" spc="-1" kern="0">
+                <a:solidFill>
+                  <a:srgbClr val="6B6A66"/>
+                </a:solidFill>
+                <a:latin typeface="Be Vietnam Pro" pitchFamily="34" charset="0"/>
+                <a:ea typeface="Be Vietnam Pro" pitchFamily="34" charset="-122"/>
+                <a:cs typeface="Be Vietnam Pro" pitchFamily="34" charset="-120"/>
+              </a:rPr>
+              <a:t> lệ: nối</a:t>
+            </a:r>
+            <a:r>
+              <a:rPr lang="en-US" sz="1800" dirty="0" spc="0" kern="0">
+                <a:solidFill>
+                  <a:srgbClr val="6B6A66"/>
+                </a:solidFill>
+                <a:latin typeface="Be Vietnam Pro" pitchFamily="34" charset="0"/>
+                <a:ea typeface="Be Vietnam Pro" pitchFamily="34" charset="-122"/>
+                <a:cs typeface="Be Vietnam Pro" pitchFamily="34" charset="-120"/>
+              </a:rPr>
+              <a:t> lại</a:t>
+            </a:r>
+            <a:r>
+              <a:rPr lang="en-US" sz="1800" dirty="0" spc="-2" kern="0">
+                <a:solidFill>
+                  <a:srgbClr val="6B6A66"/>
+                </a:solidFill>
+                <a:latin typeface="Be Vietnam Pro" pitchFamily="34" charset="0"/>
+                <a:ea typeface="Be Vietnam Pro" pitchFamily="34" charset="-122"/>
+                <a:cs typeface="Be Vietnam Pro" pitchFamily="34" charset="-120"/>
+              </a:rPr>
+              <a:t> phiên</a:t>
+            </a:r>
+            <a:r>
+              <a:rPr lang="en-US" sz="1800" dirty="0" spc="-9" kern="0">
+                <a:solidFill>
+                  <a:srgbClr val="6B6A66"/>
+                </a:solidFill>
+                <a:latin typeface="Be Vietnam Pro" pitchFamily="34" charset="0"/>
+                <a:ea typeface="Be Vietnam Pro" pitchFamily="34" charset="-122"/>
+                <a:cs typeface="Be Vietnam Pro" pitchFamily="34" charset="-120"/>
+              </a:rPr>
+              <a:t> với</a:t>
+            </a:r>
+            <a:r>
+              <a:rPr lang="en-US" sz="1800" dirty="0" spc="0" kern="0">
+                <a:solidFill>
+                  <a:srgbClr val="6B6A66"/>
+                </a:solidFill>
+                <a:latin typeface="Be Vietnam Pro" pitchFamily="34" charset="0"/>
+                <a:ea typeface="Be Vietnam Pro" pitchFamily="34" charset="-122"/>
+                <a:cs typeface="Be Vietnam Pro" pitchFamily="34" charset="-120"/>
+              </a:rPr>
+              <a:t> dữ</a:t>
+            </a:r>
+            <a:r>
+              <a:rPr lang="en-US" sz="1800" dirty="0" spc="-2" kern="0">
+                <a:solidFill>
+                  <a:srgbClr val="6B6A66"/>
+                </a:solidFill>
+                <a:latin typeface="Be Vietnam Pro" pitchFamily="34" charset="0"/>
+                <a:ea typeface="Be Vietnam Pro" pitchFamily="34" charset="-122"/>
+                <a:cs typeface="Be Vietnam Pro" pitchFamily="34" charset="-120"/>
+              </a:rPr>
+              <a:t> liệu</a:t>
+            </a:r>
+            <a:r>
+              <a:rPr lang="en-US" sz="1800" dirty="0" spc="-5" kern="0">
+                <a:solidFill>
+                  <a:srgbClr val="6B6A66"/>
+                </a:solidFill>
+                <a:latin typeface="Be Vietnam Pro" pitchFamily="34" charset="0"/>
+                <a:ea typeface="Be Vietnam Pro" pitchFamily="34" charset="-122"/>
+                <a:cs typeface="Be Vietnam Pro" pitchFamily="34" charset="-120"/>
+              </a:rPr>
+              <a:t> sớm</a:t>
+            </a:r>
+            <a:r>
+              <a:rPr lang="en-US" sz="1800" dirty="0" spc="-1" kern="0">
+                <a:solidFill>
+                  <a:srgbClr val="6B6A66"/>
+                </a:solidFill>
+                <a:latin typeface="Be Vietnam Pro" pitchFamily="34" charset="0"/>
+                <a:ea typeface="Be Vietnam Pro" pitchFamily="34" charset="-122"/>
+                <a:cs typeface="Be Vietnam Pro" pitchFamily="34" charset="-120"/>
+              </a:rPr>
+              <a:t> (bài</a:t>
+            </a:r>
+            <a:r>
+              <a:rPr lang="en-US" sz="1800" dirty="0" spc="-2" kern="0">
+                <a:solidFill>
+                  <a:srgbClr val="6B6A66"/>
+                </a:solidFill>
+                <a:latin typeface="Be Vietnam Pro" pitchFamily="34" charset="0"/>
+                <a:ea typeface="Be Vietnam Pro" pitchFamily="34" charset="-122"/>
+                <a:cs typeface="Be Vietnam Pro" pitchFamily="34" charset="-120"/>
+              </a:rPr>
+              <a:t> không bàn).</a:t>
             </a:r>
             <a:endParaRPr lang="en-US" sz="1800" dirty="0"/>
           </a:p>

</xml_diff>